<commit_message>
ship: production deployment hardening, MongoDB Atlas connectivity, and fullstack remediations
</commit_message>
<xml_diff>
--- a/FinConsent-Client-Presentation.pptx
+++ b/FinConsent-Client-Presentation.pptx
@@ -3265,7 +3265,7 @@
               </a:defRPr>
             </a:pPr>
             <a:r>
-              <a:t>Purpose-built for SEBI (Investment Advisers) Regulations, 2013 Regulation 19 compliance, pre-trade capital gains tax transparency under Finance Act 2024, and Section 65B tamper-evident electronic evidence.</a:t>
+              <a:t>Engineered to support SEBI (Investment Advisers) Regulations, 2013 Regulation 19 compliance, pre-trade capital gains tax transparency under Finance Act 2024, and Section 63 of Bharatiya Sakshya Adhiniyam, 2023 (BSA) tamper-evident electronic evidence.</a:t>
             </a:r>
           </a:p>
         </p:txBody>
@@ -3345,7 +3345,7 @@
               </a:defRPr>
             </a:pPr>
             <a:r>
-              <a:t>SEBI Regulation 19 Compliance</a:t>
+              <a:t>SEBI Regulation 19 Record-Keeping</a:t>
             </a:r>
           </a:p>
           <a:p>
@@ -3357,7 +3357,7 @@
               </a:defRPr>
             </a:pPr>
             <a:r>
-              <a:t>Enforces non-discretionary prior informed client consent with a statutory 5-year cryptographic audit trail.</a:t>
+              <a:t>Operationalizes non-discretionary prior client consent with an immutable 5-year cryptographic audit trail for investment advice and rationale.</a:t>
             </a:r>
           </a:p>
         </p:txBody>
@@ -3437,7 +3437,7 @@
               </a:defRPr>
             </a:pPr>
             <a:r>
-              <a:t>Budget 2024 Tax Engine</a:t>
+              <a:t>Finance Act 2024 Tax Engine</a:t>
             </a:r>
           </a:p>
           <a:p>
@@ -3449,7 +3449,7 @@
               </a:defRPr>
             </a:pPr>
             <a:r>
-              <a:t>Automates STCG (20%) &amp; LTCG (12.5%) pre-computations with Section 234B/C quarterly advance tax alerts.</a:t>
+              <a:t>Pre-computes STCG (20%) &amp; LTCG (12.5% + 4% cess) with quarterly advance tax alerts (Section 208 / 234C).</a:t>
             </a:r>
           </a:p>
         </p:txBody>
@@ -3529,7 +3529,7 @@
               </a:defRPr>
             </a:pPr>
             <a:r>
-              <a:t>Cryptographic Evidence</a:t>
+              <a:t>Section 63 BSA Electronic Evidence</a:t>
             </a:r>
           </a:p>
           <a:p>
@@ -3541,7 +3541,7 @@
               </a:defRPr>
             </a:pPr>
             <a:r>
-              <a:t>Dual AES-256-GCM envelope encryption, 6-digit OTP, and Section 65B Indian Evidence Act certificates.</a:t>
+              <a:t>Dual-envelope AES-256-GCM encryption, 6-digit OTP verification, and tamper-evident SHA-256 compliance receipts.</a:t>
             </a:r>
           </a:p>
         </p:txBody>
@@ -3825,11 +3825,11 @@
               </a:defRPr>
             </a:pPr>
             <a:r>
-              <a:t>• Zero PII Exposure: If a magic link is forwarded, intercepted, or leaked, the recipient sees only the adviser's firm name. Zero stock holdings or tax figures are emitted.</a:t>
-            </a:r>
-            <a:br/>
-            <a:r>
-              <a:t>• Deterministic Derivation: Password formatted as Last 4 PAN digits + Date of Birth (DDMMYYYY). Example: Rohan's PAN ABCDE1234F + 14/08/1978 = 123414081978.</a:t>
+              <a:t>• Zero PII Exposure Prior to Unlock: If a magic link is forwarded, intercepted, or leaked, the recipient sees only the adviser's firm name. Zero stock holdings or tax figures are emitted.</a:t>
+            </a:r>
+            <a:br/>
+            <a:r>
+              <a:t>• Deterministic Verification PIN: Password formatted as Last 4 PAN digits + Date of Birth (DDMMYYYY). Example: Rohan's PAN XXXXX1234F + 14/08/1978 = 123414081978.</a:t>
             </a:r>
             <a:br/>
             <a:r>
@@ -3837,7 +3837,7 @@
             </a:r>
             <a:br/>
             <a:r>
-              <a:t>• Brute-Force Rate Limiting: 5 consecutive failed attempts trigger an automatic 15-minute security lockout (HTTP 429).</a:t>
+              <a:t>• Online &amp; Offline Defenses: Acknowledges finite PIN entropy (~10^12 combinations); defended online by sliding-window rate limiters (5 failed attempts -&gt; 15 min lockout) and offline by salted PBKDF2.</a:t>
             </a:r>
           </a:p>
         </p:txBody>
@@ -4125,7 +4125,7 @@
             </a:r>
             <a:br/>
             <a:r>
-              <a:t>• Zero Cross-RIA Data Leakage: RIA 1 attempting to query Client 201 or Mandate 101 of RIA 2 receives an immediate HTTP 403 Forbidden with zero data disclosure.</a:t>
+              <a:t>• Zero Cross-RIA Data Leakage: RIA 1 attempting to query Client or Mandate of RIA 2 receives an immediate HTTP 403 Forbidden with zero data disclosure.</a:t>
             </a:r>
             <a:br/>
             <a:r>
@@ -4464,7 +4464,7 @@
               </a:defRPr>
             </a:pPr>
             <a:r>
-              <a:t>• Server Wrapping: DEK encrypted with Server Master Key via AES-256-GCM for RIA dashboard access.</a:t>
+              <a:t>• Server Wrapping: DEK encrypted with isolated Server Master Key (SERVER_MASTER_KEY) via AES-256-GCM for RIA dashboard access.</a:t>
             </a:r>
             <a:br/>
             <a:r>
@@ -4571,7 +4571,7 @@
             </a:r>
             <a:br/>
             <a:r>
-              <a:t>• In-Transit Security: Forced TLS 1.3 with Helmet HSTS (1-year max-age).</a:t>
+              <a:t>• In-Transit Security: Forced TLS 1.3 with Helmet HSTS (1-year max-age: 31,536,000 seconds).</a:t>
             </a:r>
             <a:br/>
             <a:r>
@@ -4704,7 +4704,7 @@
               </a:defRPr>
             </a:pPr>
             <a:r>
-              <a:t>Statutory multi-factor verification guaranteeing explicit non-discretionary consent.</a:t>
+              <a:t>Statutory verification guaranteeing explicit non-discretionary consent.</a:t>
             </a:r>
           </a:p>
         </p:txBody>
@@ -4859,11 +4859,11 @@
               </a:defRPr>
             </a:pPr>
             <a:r>
-              <a:t>• Mandatory Declarations: Clients must actively check 3 statutory declarations (Regulation 19 Informed Consent, Capital Gains Acceptance, Section 65B Electronic Evidence).</a:t>
-            </a:r>
-            <a:br/>
-            <a:r>
-              <a:t>• Dynamic 6-Digit OTP: Generated via CSPRNG with 5-minute Time-To-Live (TTL).</a:t>
+              <a:t>• Mandatory Declarations: Clients must actively check 3 statutory declarations (Regulation 19 Informed Consent, Capital Gains Acceptance, Section 63 BSA Electronic Evidence).</a:t>
+            </a:r>
+            <a:br/>
+            <a:r>
+              <a:t>• Dynamic 6-Digit OTP: Generated via CSPRNG with 5-minute Time-To-Live (TTL); delivered via registered email and in-app display (SMS disabled by policy; WhatsApp roadmap).</a:t>
             </a:r>
             <a:br/>
             <a:r>
@@ -5000,7 +5000,7 @@
               </a:defRPr>
             </a:pPr>
             <a:r>
-              <a:t>Chained SHA-256 audit ledger meeting Section 65B and Regulation 19 standards.</a:t>
+              <a:t>Chained SHA-256 audit ledger meeting Section 63 BSA and SEBI Regulation 19 standards.</a:t>
             </a:r>
           </a:p>
         </p:txBody>
@@ -5060,7 +5060,7 @@
               </a:defRPr>
             </a:pPr>
             <a:r>
-              <a:t>Figure 14.1: Section 65B Indian Evidence Act Compliance Receipt issued upon successful consent.</a:t>
+              <a:t>Figure 14.1: Section 63 BSA / Section 65B Compliance Receipt issued upon successful consent.</a:t>
             </a:r>
           </a:p>
         </p:txBody>
@@ -5159,11 +5159,11 @@
             </a:r>
             <a:br/>
             <a:r>
-              <a:t>• Section 65B Certificate: Captures client device IP (49.36.110.12), browser User-Agent, exact IST timestamp, and masked PAN (AB*****4F).</a:t>
-            </a:r>
-            <a:br/>
-            <a:r>
-              <a:t>• 5-Year Regulatory Preservation: Designed to satisfy SEBI Regulation 19 mandatory 5-year retention requirements.</a:t>
+              <a:t>• Section 63 BSA Certificate: Captures client device IP (RFC 5737 203.0.113.12), browser User-Agent, exact IST timestamp, and masked PAN (XXXXX1234F).</a:t>
+            </a:r>
+            <a:br/>
+            <a:r>
+              <a:t>• 5-Year Regulatory Preservation: Designed to satisfy SEBI Regulation 19 mandatory 5-year retention requirements for investment advice and rationale.</a:t>
             </a:r>
             <a:br/>
             <a:r>
@@ -5369,7 +5369,7 @@
           <a:lstStyle/>
           <a:p>
             <a:pPr>
-              <a:defRPr sz="1100">
+              <a:defRPr sz="1050">
                 <a:solidFill>
                   <a:srgbClr val="0A192F"/>
                 </a:solidFill>
@@ -5377,103 +5377,127 @@
               </a:defRPr>
             </a:pPr>
             <a:r>
-              <a:t>                     ┌──────────────────────────────────────────────┐</a:t>
-            </a:r>
-            <a:br/>
-            <a:r>
-              <a:t>                     │                                              │</a:t>
-            </a:r>
-            <a:br/>
-            <a:r>
-              <a:t>                     ▼                                              │</a:t>
-            </a:r>
-            <a:br/>
-            <a:r>
-              <a:t>                ┌─────────┐      RIA Dispatches Link       ┌──────────┐</a:t>
-            </a:r>
-            <a:br/>
-            <a:r>
-              <a:t>                │  DRAFT  │ ─────────────────────────────&gt; │   SENT   │</a:t>
-            </a:r>
-            <a:br/>
-            <a:r>
-              <a:t>                └─────────┘                                └──────────┘</a:t>
-            </a:r>
-            <a:br/>
-            <a:r>
-              <a:t>                     │                                          │</a:t>
-            </a:r>
-            <a:br/>
-            <a:r>
-              <a:t>                     │                                          │ Client Inputs</a:t>
-            </a:r>
-            <a:br/>
-            <a:r>
-              <a:t>                     │                                          │ PAN + DOB Password</a:t>
-            </a:r>
-            <a:br/>
-            <a:r>
-              <a:t>                     │                                          ▼</a:t>
-            </a:r>
-            <a:br/>
-            <a:r>
-              <a:t>                     │                                     ┌──────────┐</a:t>
-            </a:r>
-            <a:br/>
-            <a:r>
-              <a:t>                     │                                     │  VIEWED  │ (In Review)</a:t>
-            </a:r>
-            <a:br/>
-            <a:r>
-              <a:t>                     │                                     └──────────┘</a:t>
-            </a:r>
-            <a:br/>
-            <a:r>
-              <a:t>                     │                                          │</a:t>
-            </a:r>
-            <a:br/>
-            <a:r>
-              <a:t>                     │                                          │ 1. Accept Declarations</a:t>
-            </a:r>
-            <a:br/>
-            <a:r>
-              <a:t>                     │ 48-Hour Cutoff                           │ 2. Verify 6-Digit OTP</a:t>
-            </a:r>
-            <a:br/>
-            <a:r>
-              <a:t>                     │ Elapsed                                  ▼</a:t>
-            </a:r>
-            <a:br/>
-            <a:r>
-              <a:t>                     │                                     ┌───────────┐</a:t>
-            </a:r>
-            <a:br/>
-            <a:r>
-              <a:t>                     └───────────────────────────────────&gt; │ CONSENTED │ (Immutable Lock)</a:t>
-            </a:r>
-            <a:br/>
-            <a:r>
-              <a:t>                                                           └───────────┘</a:t>
-            </a:r>
-            <a:br/>
-            <a:r>
-              <a:t>                                                                │</a:t>
-            </a:r>
-            <a:br/>
-            <a:r>
-              <a:t>                                                                ▼</a:t>
-            </a:r>
-            <a:br/>
-            <a:r>
-              <a:t>                                                           ┌───────────┐</a:t>
-            </a:r>
-            <a:br/>
-            <a:r>
-              <a:t>                                                           │  REVOKED  │ (Manual RIA Revoke</a:t>
-            </a:r>
-            <a:br/>
-            <a:r>
-              <a:t>                                                           └───────────┘  or Expired Link)</a:t>
+              <a:t>               ┌────────────────────────────────────────────────────────┐</a:t>
+            </a:r>
+            <a:br/>
+            <a:r>
+              <a:t>               │                                                        │</a:t>
+            </a:r>
+            <a:br/>
+            <a:r>
+              <a:t>               ▼                                                        │</a:t>
+            </a:r>
+            <a:br/>
+            <a:r>
+              <a:t>          ┌─────────┐            RIA Dispatches Link       ┌──────────┐ │</a:t>
+            </a:r>
+            <a:br/>
+            <a:r>
+              <a:t>          │  DRAFT  │ ───────────────────────────────────&gt; │   SENT   │ │</a:t>
+            </a:r>
+            <a:br/>
+            <a:r>
+              <a:t>          └─────────┘                                      └──────────┘ │</a:t>
+            </a:r>
+            <a:br/>
+            <a:r>
+              <a:t>               │                                                │       │</a:t>
+            </a:r>
+            <a:br/>
+            <a:r>
+              <a:t>               │                                                │ Client Inputs</a:t>
+            </a:r>
+            <a:br/>
+            <a:r>
+              <a:t>               │                                                │ PAN + DOB Password</a:t>
+            </a:r>
+            <a:br/>
+            <a:r>
+              <a:t>               │                                                ▼       │</a:t>
+            </a:r>
+            <a:br/>
+            <a:r>
+              <a:t>               │                                           ┌──────────┐ │</a:t>
+            </a:r>
+            <a:br/>
+            <a:r>
+              <a:t>               │                                           │  VIEWED  │ │ (In Review)</a:t>
+            </a:r>
+            <a:br/>
+            <a:r>
+              <a:t>               │                                           └──────────┘ │</a:t>
+            </a:r>
+            <a:br/>
+            <a:r>
+              <a:t>               │                                                │       │</a:t>
+            </a:r>
+            <a:br/>
+            <a:r>
+              <a:t>               │                                                │ 1. Accept Declarations</a:t>
+            </a:r>
+            <a:br/>
+            <a:r>
+              <a:t>               │ 48-Hour Cutoff                                 │ 2. Verify 6-Digit OTP</a:t>
+            </a:r>
+            <a:br/>
+            <a:r>
+              <a:t>               │ Elapsed                                        ▼       │</a:t>
+            </a:r>
+            <a:br/>
+            <a:r>
+              <a:t>               │                                           ┌───────────┐│</a:t>
+            </a:r>
+            <a:br/>
+            <a:r>
+              <a:t>               ├─────────────────────────────────────────&gt; │ CONSENTED ││ (Immutable Lock)</a:t>
+            </a:r>
+            <a:br/>
+            <a:r>
+              <a:t>               │                                           └───────────┘│</a:t>
+            </a:r>
+            <a:br/>
+            <a:r>
+              <a:t>               │                                                        │</a:t>
+            </a:r>
+            <a:br/>
+            <a:r>
+              <a:t>               │ Advisory Revocation / Market Drift                     │</a:t>
+            </a:r>
+            <a:br/>
+            <a:r>
+              <a:t>               ▼                                                        │</a:t>
+            </a:r>
+            <a:br/>
+            <a:r>
+              <a:t>          ┌─────────┐                                                   │</a:t>
+            </a:r>
+            <a:br/>
+            <a:r>
+              <a:t>          │ REVOKED │ &lt;─────────────────────────────────────────────────┘ (Manual RIA Revoke)</a:t>
+            </a:r>
+            <a:br/>
+            <a:r>
+              <a:t>          └─────────┘</a:t>
+            </a:r>
+            <a:br/>
+            <a:r>
+              <a:t>               ▲</a:t>
+            </a:r>
+            <a:br/>
+            <a:r>
+              <a:t>               │ Cutoff Elapsed Prior to Consent</a:t>
+            </a:r>
+            <a:br/>
+            <a:r>
+              <a:t>          ┌─────────┐</a:t>
+            </a:r>
+            <a:br/>
+            <a:r>
+              <a:t>          │ EXPIRED │ (48h Window Elapsed)</a:t>
+            </a:r>
+            <a:br/>
+            <a:r>
+              <a:t>          └─────────┘</a:t>
             </a:r>
           </a:p>
         </p:txBody>
@@ -5769,7 +5793,7 @@
             </a:r>
             <a:br/>
             <a:r>
-              <a:t>• Uncompromising Consent Rail: Trade execution strictly requires formal statutory declaration checkboxes followed by 6-digit Mobile OTP verification.</a:t>
+              <a:t>• Uncompromising Consent Rail: Trade authorization strictly requires formal statutory declaration checkboxes followed by 6-digit OTP verification.</a:t>
             </a:r>
           </a:p>
         </p:txBody>
@@ -5898,7 +5922,7 @@
               </a:defRPr>
             </a:pPr>
             <a:r>
-              <a:t>Eliminating investor tax shocks with pre-trade Union Budget 2024 calculations.</a:t>
+              <a:t>Eliminating investor tax shocks with pre-trade Finance Act 2024 calculations.</a:t>
             </a:r>
           </a:p>
         </p:txBody>
@@ -5978,7 +6002,7 @@
               </a:defRPr>
             </a:pPr>
             <a:r>
-              <a:t>Union Budget 2024 Statutory Engine</a:t>
+              <a:t>Finance Act 2024 Statutory Engine</a:t>
             </a:r>
           </a:p>
           <a:p>
@@ -5986,7 +6010,7 @@
               <a:spcBef>
                 <a:spcPts val="800"/>
               </a:spcBef>
-              <a:defRPr sz="1100">
+              <a:defRPr sz="1050">
                 <a:solidFill>
                   <a:srgbClr val="475569"/>
                 </a:solidFill>
@@ -6014,11 +6038,11 @@
             </a:r>
             <a:br/>
             <a:r>
-              <a:t>  Applied above ₹1,25,000 exemption limit.</a:t>
-            </a:r>
-            <a:br/>
-            <a:r>
-              <a:t>  ₹1,25,000 gain on HDFC Bank is 100% exempt = ₹0</a:t>
+              <a:t>  Applied above annual aggregate ₹1,25,000 exemption limit.</a:t>
+            </a:r>
+            <a:br/>
+            <a:r>
+              <a:t>  ₹1,25,000 gain on HDFC Bank is exempt = ₹0</a:t>
             </a:r>
             <a:br/>
             <a:br/>
@@ -6028,7 +6052,12 @@
             <a:br/>
             <a:br/>
             <a:r>
-              <a:t>• Total Rupee Tax Liability: ₹11,440</a:t>
+              <a:t>• Estimated Rupee Tax Liability: ₹11,440</a:t>
+            </a:r>
+            <a:br/>
+            <a:br/>
+            <a:r>
+              <a:t>• Tax Disclaimers: Excludes individual surcharges (up to 15% on equity capital gains) and prior carried-forward losses. Decision-support estimate only.</a:t>
             </a:r>
           </a:p>
         </p:txBody>
@@ -6108,7 +6137,7 @@
               </a:defRPr>
             </a:pPr>
             <a:r>
-              <a:t>Advance Tax Compliance Calendar (Sec 234B &amp; 234C)</a:t>
+              <a:t>Advance Tax Planning &amp; Caveats (Sec 208 &amp; 234C)</a:t>
             </a:r>
           </a:p>
           <a:p>
@@ -6116,14 +6145,14 @@
               <a:spcBef>
                 <a:spcPts val="800"/>
               </a:spcBef>
-              <a:defRPr sz="1100">
+              <a:defRPr sz="1050">
                 <a:solidFill>
                   <a:srgbClr val="475569"/>
                 </a:solidFill>
               </a:defRPr>
             </a:pPr>
             <a:r>
-              <a:t>When net estimated gains exceed ₹1,00,000, FinConsent automatically generates an Advance Tax Banner detailing quarterly installment deadlines:</a:t>
+              <a:t>Advance tax applies when estimated net annual tax liability reaches or exceeds ₹10,000, displaying statutory installment deadlines:</a:t>
             </a:r>
             <a:br/>
             <a:br/>
@@ -6145,7 +6174,7 @@
             <a:br/>
             <a:br/>
             <a:r>
-              <a:t>Protects clients against 1% monthly statutory penal interest for deferred tax compliance.</a:t>
+              <a:t>• Proviso to Section 234C: Relieves penal interest for installments prior to the capital gains realization date if remaining tax is paid in subsequent installments.</a:t>
             </a:r>
           </a:p>
         </p:txBody>
@@ -6261,7 +6290,7 @@
               </a:defRPr>
             </a:pPr>
             <a:r>
-              <a:t>Multilingual Localization: 8 Indian Languages</a:t>
+              <a:t>Multilingual Localization Capability: 8 Languages</a:t>
             </a:r>
           </a:p>
           <a:p>
@@ -6274,7 +6303,7 @@
               </a:defRPr>
             </a:pPr>
             <a:r>
-              <a:t>Delivering advisory transparency in the investor's native language.</a:t>
+              <a:t>Delivering advisory transparency in regional and international languages.</a:t>
             </a:r>
           </a:p>
         </p:txBody>
@@ -6369,11 +6398,11 @@
               </a:defRPr>
             </a:pPr>
             <a:r>
-              <a:t>• 8 Supported Indian Languages: English (en), Hindi (hi), Marathi (mr), Gujarati (gu), Tamil (ta), Telugu (te), Kannada (kn), Bengali (bn).</a:t>
-            </a:r>
-            <a:br/>
-            <a:r>
-              <a:t>• Universal Accessibility: HNIs across Tier 1, 2, and 3 wealth corridors review proposals, disclosures, and receipts in their preferred regional language.</a:t>
+              <a:t>• 8 Supported Languages: English (en), Hindi (hi), Tamil (ta), Bengali (bn), Gujarati (gu), German (de), Japanese (ja), Korean (ko).</a:t>
+            </a:r>
+            <a:br/>
+            <a:r>
+              <a:t>• Universal Accessibility: HNIs review proposals, disclosures, and receipts in their preferred language.</a:t>
             </a:r>
             <a:br/>
             <a:r>
@@ -6623,7 +6652,7 @@
             </a:r>
             <a:br/>
             <a:r>
-              <a:t>│   • JWT Auth &amp; Distributed Session Blacklist           • Distributed Sliding Rate Limit│</a:t>
+              <a:t>│   • JWT Auth &amp; TOTP Staff MFA                          • Distributed Sliding Rate Limit│</a:t>
             </a:r>
             <a:br/>
             <a:r>
@@ -6647,7 +6676,7 @@
             </a:r>
             <a:br/>
             <a:r>
-              <a:t>│   • Mandate State Machine Engine                       • Union Budget 2024 Tax Engine  │</a:t>
+              <a:t>│   • Mandate State Machine Engine                       • Finance Act 2024 Tax Engine   │</a:t>
             </a:r>
             <a:br/>
             <a:r>
@@ -6675,7 +6704,7 @@
             </a:r>
             <a:br/>
             <a:r>
-              <a:t>│   • MongoDB Atlas (AWS Mumbai ap-south-1)              • Redis / Cluster SharedState   │</a:t>
+              <a:t>│   • MongoDB Atlas (AWS Mumbai ap-south-1)              • Dedicated SERVER_MASTER_KEY   │</a:t>
             </a:r>
             <a:br/>
             <a:r>
@@ -6799,7 +6828,7 @@
               </a:defRPr>
             </a:pPr>
             <a:r>
-              <a:t>The Problem: The High-Stakes Friction in Indian Wealth Advisory</a:t>
+              <a:t>The Problem: High-Stakes Friction in Indian Wealth Advisory</a:t>
             </a:r>
           </a:p>
           <a:p>
@@ -6812,7 +6841,7 @@
               </a:defRPr>
             </a:pPr>
             <a:r>
-              <a:t>Why legacy approval methods fail both advisory firms and high-net-worth investors.</a:t>
+              <a:t>Why legacy approval channels fail both advisory practices and high-net-worth investors.</a:t>
             </a:r>
           </a:p>
         </p:txBody>
@@ -6907,11 +6936,11 @@
               </a:defRPr>
             </a:pPr>
             <a:r>
-              <a:t>• Advisors routinely collect approvals via WhatsApp, emails, or phone notes.</a:t>
-            </a:r>
-            <a:br/>
-            <a:r>
-              <a:t>• SEBI inspection teams reject informal text messages as non-compliant with Regulation 19.</a:t>
+              <a:t>• Advisers routinely collect approvals via WhatsApp texts, email replies, or unrecorded phone calls.</a:t>
+            </a:r>
+            <a:br/>
+            <a:r>
+              <a:t>• SEBI inspection teams reject informal text messages as non-compliant with Regulation 19 record-keeping rules.</a:t>
             </a:r>
             <a:br/>
             <a:r>
@@ -6919,7 +6948,7 @@
             </a:r>
             <a:br/>
             <a:r>
-              <a:t>• Zero legal admissibility under Section 65B of the Indian Evidence Act.</a:t>
+              <a:t>• Inadmissible under Section 63 BSA / Section 65B without certified cryptographic hash continuity and device provenance.</a:t>
             </a:r>
           </a:p>
         </p:txBody>
@@ -7014,7 +7043,7 @@
               </a:defRPr>
             </a:pPr>
             <a:r>
-              <a:t>• Union Budget 2024 increased STCG to 20% and LTCG to 12.5%.</a:t>
+              <a:t>• Finance Act 2024 revised STCG to 20% and LTCG to 12.5% (+ 4% cess).</a:t>
             </a:r>
             <a:br/>
             <a:r>
@@ -7026,7 +7055,7 @@
             </a:r>
             <a:br/>
             <a:r>
-              <a:t>• Advance tax penal interest (Sections 234B &amp; 234C) erodes investor trust and fee satisfaction.</a:t>
+              <a:t>• Advance tax penal interest (Sections 208, 234B &amp; 234C where liability &gt;= ₹10,000) erodes investor trust and fee satisfaction.</a:t>
             </a:r>
           </a:p>
         </p:txBody>
@@ -7425,7 +7454,7 @@
             </a:r>
             <a:br/>
             <a:r>
-              <a:t>• Expired / Replay Attacks: Opening links past the 48-hour cutoff or after successful consent returns HTTP 410 Expired / Revoked.</a:t>
+              <a:t>• Expired / Replay Attacks: Opening links past the 48-hour cutoff or after successful consent returns HTTP 410 Gone / Revoked.</a:t>
             </a:r>
             <a:br/>
             <a:r>
@@ -8115,7 +8144,7 @@
               </a:defRPr>
             </a:pPr>
             <a:r>
-              <a:t>Compliance with SEBI Cybersecurity Framework and RBI data localization mandates.</a:t>
+              <a:t>Compliance with SEBI Cybersecurity Framework (CSCRF) and DPDP directives.</a:t>
             </a:r>
           </a:p>
         </p:txBody>
@@ -8210,7 +8239,7 @@
               </a:defRPr>
             </a:pPr>
             <a:r>
-              <a:t>• Territorial Data Residency: In strict compliance with SEBI and RBI directives, all primary databases, cryptographic keys, and audit ledgers reside exclusively in AWS Asia Pacific (Mumbai) region (ap-south-1).</a:t>
+              <a:t>• Territorial Data Residency: In strict compliance with SEBI CSCRF and DPDP Act directives, all primary databases, cryptographic keys, and audit ledgers reside exclusively in AWS Asia Pacific (Mumbai) region (ap-south-1).</a:t>
             </a:r>
             <a:br/>
             <a:r>
@@ -8218,11 +8247,15 @@
             </a:r>
             <a:br/>
             <a:r>
-              <a:t>• Orchestration: docker-compose.yml with production environment boundaries and health checks.</a:t>
-            </a:r>
-            <a:br/>
-            <a:r>
-              <a:t>• Zero Third-Party Tracking: Zero external advertising pixels, external analytics beacons, or overseas CDN assets.</a:t>
+              <a:t>• Orchestration &amp; Health: Container architecture with production environment boundaries and automated /api/health checks.</a:t>
+            </a:r>
+            <a:br/>
+            <a:r>
+              <a:t>• Key Isolation: Envelope Server Master Key (SERVER_MASTER_KEY) isolated from application authentication secrets (JWT_SECRET).</a:t>
+            </a:r>
+            <a:br/>
+            <a:r>
+              <a:t>• Zero Third-Party Tracking: Zero external advertising pixels, external analytics beacons, or overseas CDN assets, ensuring complete client privacy.</a:t>
             </a:r>
           </a:p>
         </p:txBody>
@@ -8338,7 +8371,7 @@
               </a:defRPr>
             </a:pPr>
             <a:r>
-              <a:t>Business Value &amp; Measurable Outcomes for Advisory Practices</a:t>
+              <a:t>Business Value &amp; Practice Impact for Advisory Firms</a:t>
             </a:r>
           </a:p>
           <a:p>
@@ -8431,7 +8464,7 @@
               </a:defRPr>
             </a:pPr>
             <a:r>
-              <a:t>100% Audit Readiness</a:t>
+              <a:t>Inspection-Ready Compliance</a:t>
             </a:r>
           </a:p>
           <a:p>
@@ -8446,15 +8479,15 @@
               </a:defRPr>
             </a:pPr>
             <a:r>
-              <a:t>• Pass SEBI regulatory inspections instantly with downloadable Section 65B compliance dossiers.</a:t>
-            </a:r>
-            <a:br/>
-            <a:r>
-              <a:t>• Eliminate 30+ hours of manual audit trail compilation per quarter.</a:t>
-            </a:r>
-            <a:br/>
-            <a:r>
-              <a:t>• Protect RIA license and principal officers from statutory liability.</a:t>
+              <a:t>• Downloadable Section 63 BSA / Section 65B compliance dossiers provide contemporaneous regulatory evidence.</a:t>
+            </a:r>
+            <a:br/>
+            <a:r>
+              <a:t>• Replaces weeks of manual audit trail compilation with instantaneous verification.</a:t>
+            </a:r>
+            <a:br/>
+            <a:r>
+              <a:t>• Safeguards RIA practice and principal officers against claims of unauthorized or discretionary trading.</a:t>
             </a:r>
           </a:p>
         </p:txBody>
@@ -8534,7 +8567,7 @@
               </a:defRPr>
             </a:pPr>
             <a:r>
-              <a:t>Zero Client Tax Shocks</a:t>
+              <a:t>Pre-Trade Tax Transparency</a:t>
             </a:r>
           </a:p>
           <a:p>
@@ -8549,15 +8582,15 @@
               </a:defRPr>
             </a:pPr>
             <a:r>
-              <a:t>• Complete pre-trade capital gains tax visibility builds deep investor trust.</a:t>
-            </a:r>
-            <a:br/>
-            <a:r>
-              <a:t>• Protect clients from quarterly advance tax penalties (Sections 234B &amp; 234C).</a:t>
-            </a:r>
-            <a:br/>
-            <a:r>
-              <a:t>• Elevate advisory relationship from transaction chasing to strategic planning.</a:t>
+              <a:t>• Complete pre-trade capital gains tax visibility eliminates investor surprise.</a:t>
+            </a:r>
+            <a:br/>
+            <a:r>
+              <a:t>• Proactively alerts clients to quarterly advance tax obligations under Section 208 and 234C.</a:t>
+            </a:r>
+            <a:br/>
+            <a:r>
+              <a:t>• Elevates advisory relationship from administrative chasing to high-trust strategic wealth planning.</a:t>
             </a:r>
           </a:p>
         </p:txBody>
@@ -8637,7 +8670,7 @@
               </a:defRPr>
             </a:pPr>
             <a:r>
-              <a:t>75% Faster Authorization</a:t>
+              <a:t>Streamlined Mobile Turnaround</a:t>
             </a:r>
           </a:p>
           <a:p>
@@ -8652,15 +8685,15 @@
               </a:defRPr>
             </a:pPr>
             <a:r>
-              <a:t>• Reduce client consent turnaround from 3–5 days to under 2 hours on mobile.</a:t>
-            </a:r>
-            <a:br/>
-            <a:r>
-              <a:t>• Minimize market slippage during high-volatility rebalancing windows.</a:t>
-            </a:r>
-            <a:br/>
-            <a:r>
-              <a:t>• Seamless 1-click WhatsApp delivery with zero login friction.</a:t>
+              <a:t>• Accelerates client review and consent turnaround to under 2 hours on mobile.</a:t>
+            </a:r>
+            <a:br/>
+            <a:r>
+              <a:t>• Minimizes market slippage during high-volatility rebalancing windows.</a:t>
+            </a:r>
+            <a:br/>
+            <a:r>
+              <a:t>• Secure password-protected magic link delivery without requiring client app installation.</a:t>
             </a:r>
           </a:p>
         </p:txBody>
@@ -8980,7 +9013,7 @@
                         </a:defRPr>
                       </a:pPr>
                       <a:r>
-                        <a:t>Post-trade surprise tax bill; penal interest under Sections 234B/C.</a:t>
+                        <a:t>Post-trade surprise tax bill; penal interest under Sections 208 &amp; 234B/C.</a:t>
                       </a:r>
                     </a:p>
                   </a:txBody>
@@ -8999,7 +9032,7 @@
                         </a:defRPr>
                       </a:pPr>
                       <a:r>
-                        <a:t>Pre-trade Union Budget 2024 calculation with quarterly advance tax alert.</a:t>
+                        <a:t>Pre-trade Finance Act 2024 calculation with quarterly advance tax alert.</a:t>
                       </a:r>
                     </a:p>
                   </a:txBody>
@@ -9098,7 +9131,7 @@
                         </a:defRPr>
                       </a:pPr>
                       <a:r>
-                        <a:t>Scattered screenshots and PDFs; inadmissible under Section 65B.</a:t>
+                        <a:t>Scattered screenshots and PDFs; inadmissible under Section 63 BSA.</a:t>
                       </a:r>
                     </a:p>
                   </a:txBody>
@@ -9117,7 +9150,7 @@
                         </a:defRPr>
                       </a:pPr>
                       <a:r>
-                        <a:t>Append-only forward SHA-256 ledger emitting certified Section 65B compliance dossier.</a:t>
+                        <a:t>Append-only forward SHA-256 ledger emitting certified Section 63 BSA compliance dossier.</a:t>
                       </a:r>
                     </a:p>
                   </a:txBody>
@@ -9223,7 +9256,7 @@
               </a:defRPr>
             </a:pPr>
             <a:r>
-              <a:t>NEXT STEPS</a:t>
+              <a:t>APPENDIX A</a:t>
             </a:r>
           </a:p>
           <a:p>
@@ -9239,7 +9272,7 @@
               </a:defRPr>
             </a:pPr>
             <a:r>
-              <a:t>Conclusion &amp; Next Steps: Deploying FinConsent</a:t>
+              <a:t>Technical Deep-Dive: Cryptographic Invariants &amp; Key Derivation</a:t>
             </a:r>
           </a:p>
           <a:p>
@@ -9252,7 +9285,7 @@
               </a:defRPr>
             </a:pPr>
             <a:r>
-              <a:t>Accelerating advisory compliance, investor trust, and practice scalability.</a:t>
+              <a:t>Formal mathematical specifications for envelope encryption and PBKDF2 KDF.</a:t>
             </a:r>
           </a:p>
         </p:txBody>
@@ -9325,41 +9358,45 @@
           <a:lstStyle/>
           <a:p>
             <a:pPr>
-              <a:defRPr b="1" sz="1400">
+              <a:defRPr b="1" sz="1300">
                 <a:solidFill>
                   <a:srgbClr val="0A192F"/>
                 </a:solidFill>
               </a:defRPr>
             </a:pPr>
             <a:r>
-              <a:t>Implementation &amp; Onboarding Path</a:t>
+              <a:t>Cryptographic Implementation Specifications</a:t>
             </a:r>
           </a:p>
           <a:p>
             <a:pPr>
               <a:spcBef>
-                <a:spcPts val="1000"/>
+                <a:spcPts val="800"/>
               </a:spcBef>
-              <a:defRPr sz="1150">
+              <a:defRPr sz="1100">
                 <a:solidFill>
                   <a:srgbClr val="475569"/>
                 </a:solidFill>
               </a:defRPr>
             </a:pPr>
             <a:r>
-              <a:t>1. Immediate Compliance Upgrade: Onboard RIA practice in under 10 minutes; configure SEBI INA registration number and firm compliance contacts.</a:t>
-            </a:r>
-            <a:br/>
-            <a:r>
-              <a:t>2. Client Roster Migration: Import advisory clients with validated PANs, mobile numbers, and DOB attributes.</a:t>
-            </a:r>
-            <a:br/>
-            <a:r>
-              <a:t>3. Pilot Rebalancing Run: Execute live mandates with select client families to demonstrate pre-trade tax transparency and frictionless mobile OTP consent.</a:t>
-            </a:r>
-            <a:br/>
-            <a:r>
-              <a:t>4. Regulatory Peace of Mind: Rest assured knowing every trade authorization is cryptographically preserved in AWS Mumbai under Section 65B standards.</a:t>
+              <a:t>• Cipher: AES-256-GCM (Galois/Counter Mode) with 12-byte random IV and 16-byte authentication tag.</a:t>
+            </a:r>
+            <a:br/>
+            <a:r>
+              <a:t>• Key Derivation Function: PBKDF2 with SHA-256 digest, 100,000 rounds in production (1,000 in test mode), and 16-byte random salt.</a:t>
+            </a:r>
+            <a:br/>
+            <a:r>
+              <a:t>• Key Derivation Input: Normalized string concatenation of PAN last 4 digits + DOB in DDMMYYYY format.</a:t>
+            </a:r>
+            <a:br/>
+            <a:r>
+              <a:t>• Dual Wrapping: Server DEK wrapped with isolated SERVER_MASTER_KEY; Client DEK wrapped with Client Derived Key.</a:t>
+            </a:r>
+            <a:br/>
+            <a:r>
+              <a:t>• Invariant: Server never stores client plaintext password or unencrypted DEK in database.</a:t>
             </a:r>
           </a:p>
         </p:txBody>
@@ -9373,246 +9410,6 @@
 </file>
 
 <file path=ppt/slides/slide26.xml><?xml version="1.0" encoding="utf-8"?>
-<p:sld xmlns:a="http://schemas.openxmlformats.org/drawingml/2006/main" xmlns:p="http://schemas.openxmlformats.org/presentationml/2006/main" xmlns:r="http://schemas.openxmlformats.org/officeDocument/2006/relationships">
-  <p:cSld>
-    <p:spTree>
-      <p:nvGrpSpPr>
-        <p:cNvPr id="1" name=""/>
-        <p:cNvGrpSpPr/>
-        <p:nvPr/>
-      </p:nvGrpSpPr>
-      <p:grpSpPr/>
-      <p:sp>
-        <p:nvSpPr>
-          <p:cNvPr id="2" name="Rectangle 1"/>
-          <p:cNvSpPr/>
-          <p:nvPr/>
-        </p:nvSpPr>
-        <p:spPr>
-          <a:xfrm>
-            <a:off x="0" y="0"/>
-            <a:ext cx="12191695" cy="6858000"/>
-          </a:xfrm>
-          <a:prstGeom prst="rect">
-            <a:avLst/>
-          </a:prstGeom>
-          <a:solidFill>
-            <a:srgbClr val="FFFFFF"/>
-          </a:solidFill>
-          <a:ln>
-            <a:noFill/>
-          </a:ln>
-        </p:spPr>
-        <p:style>
-          <a:lnRef idx="1">
-            <a:schemeClr val="accent1"/>
-          </a:lnRef>
-          <a:fillRef idx="3">
-            <a:schemeClr val="accent1"/>
-          </a:fillRef>
-          <a:effectRef idx="2">
-            <a:schemeClr val="accent1"/>
-          </a:effectRef>
-          <a:fontRef idx="minor">
-            <a:schemeClr val="lt1"/>
-          </a:fontRef>
-        </p:style>
-        <p:txBody>
-          <a:bodyPr rtlCol="0" anchor="ctr"/>
-          <a:lstStyle/>
-          <a:p>
-            <a:pPr algn="ctr"/>
-          </a:p>
-        </p:txBody>
-      </p:sp>
-      <p:sp>
-        <p:nvSpPr>
-          <p:cNvPr id="3" name="TextBox 2"/>
-          <p:cNvSpPr txBox="1"/>
-          <p:nvPr/>
-        </p:nvSpPr>
-        <p:spPr>
-          <a:xfrm>
-            <a:off x="731520" y="365760"/>
-            <a:ext cx="10728655" cy="1188720"/>
-          </a:xfrm>
-          <a:prstGeom prst="rect">
-            <a:avLst/>
-          </a:prstGeom>
-          <a:noFill/>
-        </p:spPr>
-        <p:txBody>
-          <a:bodyPr wrap="square" lIns="0" tIns="0" rIns="0" bIns="0">
-            <a:spAutoFit/>
-          </a:bodyPr>
-          <a:lstStyle/>
-          <a:p>
-            <a:pPr>
-              <a:spcAft>
-                <a:spcPts val="200"/>
-              </a:spcAft>
-              <a:defRPr sz="950" b="1">
-                <a:solidFill>
-                  <a:srgbClr val="4F46E5"/>
-                </a:solidFill>
-                <a:latin typeface="Calibri"/>
-              </a:defRPr>
-            </a:pPr>
-            <a:r>
-              <a:t>APPENDIX A</a:t>
-            </a:r>
-          </a:p>
-          <a:p>
-            <a:pPr>
-              <a:spcAft>
-                <a:spcPts val="200"/>
-              </a:spcAft>
-              <a:defRPr sz="2200" b="1">
-                <a:solidFill>
-                  <a:srgbClr val="0A192F"/>
-                </a:solidFill>
-                <a:latin typeface="Calibri"/>
-              </a:defRPr>
-            </a:pPr>
-            <a:r>
-              <a:t>Technical Deep-Dive: Cryptographic Invariants &amp; Key Derivation</a:t>
-            </a:r>
-          </a:p>
-          <a:p>
-            <a:pPr>
-              <a:defRPr sz="1200">
-                <a:solidFill>
-                  <a:srgbClr val="475569"/>
-                </a:solidFill>
-                <a:latin typeface="Calibri"/>
-              </a:defRPr>
-            </a:pPr>
-            <a:r>
-              <a:t>Formal mathematical specifications for envelope encryption and PBKDF2 KDF.</a:t>
-            </a:r>
-          </a:p>
-        </p:txBody>
-      </p:sp>
-      <p:sp>
-        <p:nvSpPr>
-          <p:cNvPr id="4" name="Rounded Rectangle 3"/>
-          <p:cNvSpPr/>
-          <p:nvPr/>
-        </p:nvSpPr>
-        <p:spPr>
-          <a:xfrm>
-            <a:off x="731520" y="1828800"/>
-            <a:ext cx="10728655" cy="4206240"/>
-          </a:xfrm>
-          <a:prstGeom prst="roundRect">
-            <a:avLst/>
-          </a:prstGeom>
-          <a:solidFill>
-            <a:srgbClr val="F8FAFC"/>
-          </a:solidFill>
-          <a:ln w="12700">
-            <a:solidFill>
-              <a:srgbClr val="E2E8F0"/>
-            </a:solidFill>
-          </a:ln>
-        </p:spPr>
-        <p:style>
-          <a:lnRef idx="1">
-            <a:schemeClr val="accent1"/>
-          </a:lnRef>
-          <a:fillRef idx="3">
-            <a:schemeClr val="accent1"/>
-          </a:fillRef>
-          <a:effectRef idx="2">
-            <a:schemeClr val="accent1"/>
-          </a:effectRef>
-          <a:fontRef idx="minor">
-            <a:schemeClr val="lt1"/>
-          </a:fontRef>
-        </p:style>
-        <p:txBody>
-          <a:bodyPr rtlCol="0" anchor="ctr"/>
-          <a:lstStyle/>
-          <a:p>
-            <a:pPr algn="ctr"/>
-          </a:p>
-        </p:txBody>
-      </p:sp>
-      <p:sp>
-        <p:nvSpPr>
-          <p:cNvPr id="5" name="TextBox 4"/>
-          <p:cNvSpPr txBox="1"/>
-          <p:nvPr/>
-        </p:nvSpPr>
-        <p:spPr>
-          <a:xfrm>
-            <a:off x="1097280" y="2103120"/>
-            <a:ext cx="10058400" cy="3657600"/>
-          </a:xfrm>
-          <a:prstGeom prst="rect">
-            <a:avLst/>
-          </a:prstGeom>
-          <a:noFill/>
-        </p:spPr>
-        <p:txBody>
-          <a:bodyPr wrap="square">
-            <a:spAutoFit/>
-          </a:bodyPr>
-          <a:lstStyle/>
-          <a:p>
-            <a:pPr>
-              <a:defRPr b="1" sz="1300">
-                <a:solidFill>
-                  <a:srgbClr val="0A192F"/>
-                </a:solidFill>
-              </a:defRPr>
-            </a:pPr>
-            <a:r>
-              <a:t>Cryptographic Implementation Specifications</a:t>
-            </a:r>
-          </a:p>
-          <a:p>
-            <a:pPr>
-              <a:spcBef>
-                <a:spcPts val="800"/>
-              </a:spcBef>
-              <a:defRPr sz="1100">
-                <a:solidFill>
-                  <a:srgbClr val="475569"/>
-                </a:solidFill>
-              </a:defRPr>
-            </a:pPr>
-            <a:r>
-              <a:t>• Cipher: AES-256-GCM (Galois/Counter Mode) with 12-byte random IV and 16-byte authentication tag.</a:t>
-            </a:r>
-            <a:br/>
-            <a:r>
-              <a:t>• Key Derivation Function: PBKDF2 with SHA-256 digest, 100,000 rounds in production (1,000 in test mode), and 16-byte random salt.</a:t>
-            </a:r>
-            <a:br/>
-            <a:r>
-              <a:t>• Key Derivation Input: Normalized string concatenation of PAN last 4 digits + DOB in DDMMYYYY format.</a:t>
-            </a:r>
-            <a:br/>
-            <a:r>
-              <a:t>• Dual Wrapping: Server DEK wrapped with Master Key (JWT_SECRET derived); Client DEK wrapped with Client Derived Key.</a:t>
-            </a:r>
-            <a:br/>
-            <a:r>
-              <a:t>• Invariant: Server never stores client plaintext password or unencrypted DEK in database.</a:t>
-            </a:r>
-          </a:p>
-        </p:txBody>
-      </p:sp>
-    </p:spTree>
-  </p:cSld>
-  <p:clrMapOvr>
-    <a:masterClrMapping/>
-  </p:clrMapOvr>
-</p:sld>
-</file>
-
-<file path=ppt/slides/slide27.xml><?xml version="1.0" encoding="utf-8"?>
 <p:sld xmlns:a="http://schemas.openxmlformats.org/drawingml/2006/main" xmlns:p="http://schemas.openxmlformats.org/presentationml/2006/main" xmlns:r="http://schemas.openxmlformats.org/officeDocument/2006/relationships">
   <p:cSld>
     <p:spTree>
@@ -10253,6 +10050,251 @@
 </p:sld>
 </file>
 
+<file path=ppt/slides/slide27.xml><?xml version="1.0" encoding="utf-8"?>
+<p:sld xmlns:a="http://schemas.openxmlformats.org/drawingml/2006/main" xmlns:p="http://schemas.openxmlformats.org/presentationml/2006/main" xmlns:r="http://schemas.openxmlformats.org/officeDocument/2006/relationships">
+  <p:cSld>
+    <p:spTree>
+      <p:nvGrpSpPr>
+        <p:cNvPr id="1" name=""/>
+        <p:cNvGrpSpPr/>
+        <p:nvPr/>
+      </p:nvGrpSpPr>
+      <p:grpSpPr/>
+      <p:sp>
+        <p:nvSpPr>
+          <p:cNvPr id="2" name="Rectangle 1"/>
+          <p:cNvSpPr/>
+          <p:nvPr/>
+        </p:nvSpPr>
+        <p:spPr>
+          <a:xfrm>
+            <a:off x="0" y="0"/>
+            <a:ext cx="12191695" cy="6858000"/>
+          </a:xfrm>
+          <a:prstGeom prst="rect">
+            <a:avLst/>
+          </a:prstGeom>
+          <a:solidFill>
+            <a:srgbClr val="FFFFFF"/>
+          </a:solidFill>
+          <a:ln>
+            <a:noFill/>
+          </a:ln>
+        </p:spPr>
+        <p:style>
+          <a:lnRef idx="1">
+            <a:schemeClr val="accent1"/>
+          </a:lnRef>
+          <a:fillRef idx="3">
+            <a:schemeClr val="accent1"/>
+          </a:fillRef>
+          <a:effectRef idx="2">
+            <a:schemeClr val="accent1"/>
+          </a:effectRef>
+          <a:fontRef idx="minor">
+            <a:schemeClr val="lt1"/>
+          </a:fontRef>
+        </p:style>
+        <p:txBody>
+          <a:bodyPr rtlCol="0" anchor="ctr"/>
+          <a:lstStyle/>
+          <a:p>
+            <a:pPr algn="ctr"/>
+          </a:p>
+        </p:txBody>
+      </p:sp>
+      <p:sp>
+        <p:nvSpPr>
+          <p:cNvPr id="3" name="TextBox 2"/>
+          <p:cNvSpPr txBox="1"/>
+          <p:nvPr/>
+        </p:nvSpPr>
+        <p:spPr>
+          <a:xfrm>
+            <a:off x="731520" y="365760"/>
+            <a:ext cx="10728655" cy="1188720"/>
+          </a:xfrm>
+          <a:prstGeom prst="rect">
+            <a:avLst/>
+          </a:prstGeom>
+          <a:noFill/>
+        </p:spPr>
+        <p:txBody>
+          <a:bodyPr wrap="square" lIns="0" tIns="0" rIns="0" bIns="0">
+            <a:spAutoFit/>
+          </a:bodyPr>
+          <a:lstStyle/>
+          <a:p>
+            <a:pPr>
+              <a:spcAft>
+                <a:spcPts val="200"/>
+              </a:spcAft>
+              <a:defRPr sz="950" b="1">
+                <a:solidFill>
+                  <a:srgbClr val="4F46E5"/>
+                </a:solidFill>
+                <a:latin typeface="Calibri"/>
+              </a:defRPr>
+            </a:pPr>
+            <a:r>
+              <a:t>APPENDIX C</a:t>
+            </a:r>
+          </a:p>
+          <a:p>
+            <a:pPr>
+              <a:spcAft>
+                <a:spcPts val="200"/>
+              </a:spcAft>
+              <a:defRPr sz="2200" b="1">
+                <a:solidFill>
+                  <a:srgbClr val="0A192F"/>
+                </a:solidFill>
+                <a:latin typeface="Calibri"/>
+              </a:defRPr>
+            </a:pPr>
+            <a:r>
+              <a:t>Technical Deep-Dive: Audit Schema &amp; Section 63 BSA Admissibility</a:t>
+            </a:r>
+          </a:p>
+          <a:p>
+            <a:pPr>
+              <a:defRPr sz="1200">
+                <a:solidFill>
+                  <a:srgbClr val="475569"/>
+                </a:solidFill>
+                <a:latin typeface="Calibri"/>
+              </a:defRPr>
+            </a:pPr>
+            <a:r>
+              <a:t>Evidentiary record structures required by Indian legal standards.</a:t>
+            </a:r>
+          </a:p>
+        </p:txBody>
+      </p:sp>
+      <p:sp>
+        <p:nvSpPr>
+          <p:cNvPr id="4" name="Rounded Rectangle 3"/>
+          <p:cNvSpPr/>
+          <p:nvPr/>
+        </p:nvSpPr>
+        <p:spPr>
+          <a:xfrm>
+            <a:off x="731520" y="1828800"/>
+            <a:ext cx="10728655" cy="4206240"/>
+          </a:xfrm>
+          <a:prstGeom prst="roundRect">
+            <a:avLst/>
+          </a:prstGeom>
+          <a:solidFill>
+            <a:srgbClr val="F8FAFC"/>
+          </a:solidFill>
+          <a:ln w="12700">
+            <a:solidFill>
+              <a:srgbClr val="E2E8F0"/>
+            </a:solidFill>
+          </a:ln>
+        </p:spPr>
+        <p:style>
+          <a:lnRef idx="1">
+            <a:schemeClr val="accent1"/>
+          </a:lnRef>
+          <a:fillRef idx="3">
+            <a:schemeClr val="accent1"/>
+          </a:fillRef>
+          <a:effectRef idx="2">
+            <a:schemeClr val="accent1"/>
+          </a:effectRef>
+          <a:fontRef idx="minor">
+            <a:schemeClr val="lt1"/>
+          </a:fontRef>
+        </p:style>
+        <p:txBody>
+          <a:bodyPr rtlCol="0" anchor="ctr"/>
+          <a:lstStyle/>
+          <a:p>
+            <a:pPr algn="ctr"/>
+          </a:p>
+        </p:txBody>
+      </p:sp>
+      <p:sp>
+        <p:nvSpPr>
+          <p:cNvPr id="5" name="TextBox 4"/>
+          <p:cNvSpPr txBox="1"/>
+          <p:nvPr/>
+        </p:nvSpPr>
+        <p:spPr>
+          <a:xfrm>
+            <a:off x="1097280" y="2103120"/>
+            <a:ext cx="10058400" cy="3657600"/>
+          </a:xfrm>
+          <a:prstGeom prst="rect">
+            <a:avLst/>
+          </a:prstGeom>
+          <a:noFill/>
+        </p:spPr>
+        <p:txBody>
+          <a:bodyPr wrap="square">
+            <a:spAutoFit/>
+          </a:bodyPr>
+          <a:lstStyle/>
+          <a:p>
+            <a:pPr>
+              <a:defRPr b="1" sz="1300">
+                <a:solidFill>
+                  <a:srgbClr val="0A192F"/>
+                </a:solidFill>
+              </a:defRPr>
+            </a:pPr>
+            <a:r>
+              <a:t>Section 63 BSA Electronic Evidence Mandatory Attributes</a:t>
+            </a:r>
+          </a:p>
+          <a:p>
+            <a:pPr>
+              <a:spcBef>
+                <a:spcPts val="800"/>
+              </a:spcBef>
+              <a:defRPr sz="1100">
+                <a:solidFill>
+                  <a:srgbClr val="475569"/>
+                </a:solidFill>
+              </a:defRPr>
+            </a:pPr>
+            <a:r>
+              <a:t>Under Section 63 of Bharatiya Sakshya Adhiniyam, 2023 (BSA) and Section 65B of erstwhile Indian Evidence Act, secondary electronic records require:</a:t>
+            </a:r>
+            <a:br/>
+            <a:br/>
+            <a:r>
+              <a:t>1. Origin Identification: Client IP Address (RFC 5737 203.0.113.12) and browser User-Agent recorded at execution time.</a:t>
+            </a:r>
+            <a:br/>
+            <a:r>
+              <a:t>2. Synchronized Timestamp: Server-side NTP timestamping localized to Indian Standard Time (IST).</a:t>
+            </a:r>
+            <a:br/>
+            <a:r>
+              <a:t>3. Hash Integrity Seal: SHA-256 payloadHash computed over the immutable consent certificate.</a:t>
+            </a:r>
+            <a:br/>
+            <a:r>
+              <a:t>4. Device Custody Proof: Evidence that the computer system was operating properly during record generation.</a:t>
+            </a:r>
+            <a:br/>
+            <a:r>
+              <a:t>5. Regulation 19 Admissibility: Cryptographically chained forward hashes guarantee zero retroactive modifications.</a:t>
+            </a:r>
+          </a:p>
+        </p:txBody>
+      </p:sp>
+    </p:spTree>
+  </p:cSld>
+  <p:clrMapOvr>
+    <a:masterClrMapping/>
+  </p:clrMapOvr>
+</p:sld>
+</file>
+
 <file path=ppt/slides/slide28.xml><?xml version="1.0" encoding="utf-8"?>
 <p:sld xmlns:a="http://schemas.openxmlformats.org/drawingml/2006/main" xmlns:p="http://schemas.openxmlformats.org/presentationml/2006/main" xmlns:r="http://schemas.openxmlformats.org/officeDocument/2006/relationships">
   <p:cSld>
@@ -10340,7 +10382,7 @@
               </a:defRPr>
             </a:pPr>
             <a:r>
-              <a:t>APPENDIX C</a:t>
+              <a:t>APPENDIX D</a:t>
             </a:r>
           </a:p>
           <a:p>
@@ -10356,7 +10398,7 @@
               </a:defRPr>
             </a:pPr>
             <a:r>
-              <a:t>Technical Deep-Dive: Audit Schema &amp; Section 65B Admissibility</a:t>
+              <a:t>Operational Considerations: Implemented State vs. Roadmap</a:t>
             </a:r>
           </a:p>
           <a:p>
@@ -10369,7 +10411,7 @@
               </a:defRPr>
             </a:pPr>
             <a:r>
-              <a:t>Evidentiary record structures required by Indian legal standards.</a:t>
+              <a:t>Clear demarcation between current production capabilities and future roadmap milestones.</a:t>
             </a:r>
           </a:p>
         </p:txBody>
@@ -10383,7 +10425,7 @@
         <p:spPr>
           <a:xfrm>
             <a:off x="731520" y="1828800"/>
-            <a:ext cx="10728655" cy="4206240"/>
+            <a:ext cx="5120640" cy="4206240"/>
           </a:xfrm>
           <a:prstGeom prst="roundRect">
             <a:avLst/>
@@ -10427,8 +10469,8 @@
         </p:nvSpPr>
         <p:spPr>
           <a:xfrm>
-            <a:off x="1097280" y="2103120"/>
-            <a:ext cx="10058400" cy="3657600"/>
+            <a:off x="914400" y="2011680"/>
+            <a:ext cx="4754880" cy="3840480"/>
           </a:xfrm>
           <a:prstGeom prst="rect">
             <a:avLst/>
@@ -10444,12 +10486,12 @@
             <a:pPr>
               <a:defRPr b="1" sz="1300">
                 <a:solidFill>
-                  <a:srgbClr val="0A192F"/>
-                </a:solidFill>
-              </a:defRPr>
-            </a:pPr>
-            <a:r>
-              <a:t>Section 65B Electronic Evidence Mandatory Attributes</a:t>
+                  <a:srgbClr val="059669"/>
+                </a:solidFill>
+              </a:defRPr>
+            </a:pPr>
+            <a:r>
+              <a:t>Implemented Production Capabilities</a:t>
             </a:r>
           </a:p>
           <a:p>
@@ -10457,35 +10499,149 @@
               <a:spcBef>
                 <a:spcPts val="800"/>
               </a:spcBef>
-              <a:defRPr sz="1100">
+              <a:defRPr sz="1050">
                 <a:solidFill>
                   <a:srgbClr val="475569"/>
                 </a:solidFill>
               </a:defRPr>
             </a:pPr>
             <a:r>
-              <a:t>Under the Indian Evidence Act, 1872 and Information Technology Act, 2000, secondary electronic records require:</a:t>
-            </a:r>
-            <a:br/>
-            <a:br/>
-            <a:r>
-              <a:t>1. Origin Identification: Client IP Address (e.g. 49.36.110.12) and browser User-Agent recorded at execution time.</a:t>
-            </a:r>
-            <a:br/>
-            <a:r>
-              <a:t>2. Synchronized Timestamp: Server-side NTP timestamping localized to Indian Standard Time (IST).</a:t>
-            </a:r>
-            <a:br/>
-            <a:r>
-              <a:t>3. Hash Integrity Seal: SHA-256 payloadHash computed over the immutable consent certificate.</a:t>
-            </a:r>
-            <a:br/>
-            <a:r>
-              <a:t>4. Device Custody Proof: Evidence that the computer system was operating properly during the record generation.</a:t>
-            </a:r>
-            <a:br/>
-            <a:r>
-              <a:t>5. Regulation 19 Admissibility: Cryptographically chained forward hashes guarantee zero retroactive modifications.</a:t>
+              <a:t>• Full non-discretionary mandate formulation &amp; tax engine.</a:t>
+            </a:r>
+            <a:br/>
+            <a:r>
+              <a:t>• AES-256-GCM dual-envelope encryption &amp; PBKDF2 password gate.</a:t>
+            </a:r>
+            <a:br/>
+            <a:r>
+              <a:t>• 256-bit magic links with SHA-256 database hashing &amp; 48h cutoff.</a:t>
+            </a:r>
+            <a:br/>
+            <a:r>
+              <a:t>• In-app mandate chat with explicit non-consent separation.</a:t>
+            </a:r>
+            <a:br/>
+            <a:r>
+              <a:t>• Section 63 BSA electronic compliance receipts with SHA-256 hash chaining.</a:t>
+            </a:r>
+            <a:br/>
+            <a:r>
+              <a:t>• Multi-tenant isolation, RBAC, staff TOTP MFA, and distributed rate limiting.</a:t>
+            </a:r>
+            <a:br/>
+            <a:r>
+              <a:t>• 8 supported languages with English ASCII numerals.</a:t>
+            </a:r>
+          </a:p>
+        </p:txBody>
+      </p:sp>
+      <p:sp>
+        <p:nvSpPr>
+          <p:cNvPr id="6" name="Rounded Rectangle 5"/>
+          <p:cNvSpPr/>
+          <p:nvPr/>
+        </p:nvSpPr>
+        <p:spPr>
+          <a:xfrm>
+            <a:off x="6217920" y="1828800"/>
+            <a:ext cx="5242255" cy="4206240"/>
+          </a:xfrm>
+          <a:prstGeom prst="roundRect">
+            <a:avLst/>
+          </a:prstGeom>
+          <a:solidFill>
+            <a:srgbClr val="F8FAFC"/>
+          </a:solidFill>
+          <a:ln w="12700">
+            <a:solidFill>
+              <a:srgbClr val="E2E8F0"/>
+            </a:solidFill>
+          </a:ln>
+        </p:spPr>
+        <p:style>
+          <a:lnRef idx="1">
+            <a:schemeClr val="accent1"/>
+          </a:lnRef>
+          <a:fillRef idx="3">
+            <a:schemeClr val="accent1"/>
+          </a:fillRef>
+          <a:effectRef idx="2">
+            <a:schemeClr val="accent1"/>
+          </a:effectRef>
+          <a:fontRef idx="minor">
+            <a:schemeClr val="lt1"/>
+          </a:fontRef>
+        </p:style>
+        <p:txBody>
+          <a:bodyPr rtlCol="0" anchor="ctr"/>
+          <a:lstStyle/>
+          <a:p>
+            <a:pPr algn="ctr"/>
+          </a:p>
+        </p:txBody>
+      </p:sp>
+      <p:sp>
+        <p:nvSpPr>
+          <p:cNvPr id="7" name="TextBox 6"/>
+          <p:cNvSpPr txBox="1"/>
+          <p:nvPr/>
+        </p:nvSpPr>
+        <p:spPr>
+          <a:xfrm>
+            <a:off x="6492240" y="2011680"/>
+            <a:ext cx="4693615" cy="3840480"/>
+          </a:xfrm>
+          <a:prstGeom prst="rect">
+            <a:avLst/>
+          </a:prstGeom>
+          <a:noFill/>
+        </p:spPr>
+        <p:txBody>
+          <a:bodyPr wrap="square">
+            <a:spAutoFit/>
+          </a:bodyPr>
+          <a:lstStyle/>
+          <a:p>
+            <a:pPr>
+              <a:defRPr b="1" sz="1300">
+                <a:solidFill>
+                  <a:srgbClr val="4F46E5"/>
+                </a:solidFill>
+              </a:defRPr>
+            </a:pPr>
+            <a:r>
+              <a:t>Documented Scope &amp; Future Roadmap</a:t>
+            </a:r>
+          </a:p>
+          <a:p>
+            <a:pPr>
+              <a:spcBef>
+                <a:spcPts val="800"/>
+              </a:spcBef>
+              <a:defRPr sz="1050">
+                <a:solidFill>
+                  <a:srgbClr val="475569"/>
+                </a:solidFill>
+              </a:defRPr>
+            </a:pPr>
+            <a:r>
+              <a:t>• Production TRAI DLT SMS Gateway: Current setup delivers OTP via email and in-app display (SMS disabled by policy); commercial SMS requires onboarding a TRAI DLT-registered aggregator.</a:t>
+            </a:r>
+            <a:br/>
+            <a:r>
+              <a:t>• WhatsApp Channel Delivery: Currently dispatched via secure email magic links; direct WhatsApp Business API delivery is on the product roadmap.</a:t>
+            </a:r>
+            <a:br/>
+            <a:r>
+              <a:t>• CloudHSM Key Management: Envelope Server Master Key isolated via environment config; AWS CloudHSM or KMS recommended for institutional banking tiers.</a:t>
+            </a:r>
+            <a:br/>
+            <a:r>
+              <a:t>• Direct Broker Execution: FinConsent intentionally halts at locked statutory consent; execution is handled by client/broker terminal (API execution on roadmap).</a:t>
+            </a:r>
+            <a:br/>
+            <a:r>
+              <a:t>• External RFC 3161 Time Stamping: Anchoring ledger roots to an external Time Stamping Authority (TSA).</a:t>
             </a:r>
           </a:p>
         </p:txBody>
@@ -10585,7 +10741,7 @@
               </a:defRPr>
             </a:pPr>
             <a:r>
-              <a:t>APPENDIX D</a:t>
+              <a:t>PILOT PROPOSAL &amp; NEXT STEPS</a:t>
             </a:r>
           </a:p>
           <a:p>
@@ -10601,7 +10757,7 @@
               </a:defRPr>
             </a:pPr>
             <a:r>
-              <a:t>Operational Considerations &amp; Future Recommendations</a:t>
+              <a:t>Institutional Pilot Proposal &amp; Implementation Roadmap</a:t>
             </a:r>
           </a:p>
           <a:p>
@@ -10614,7 +10770,7 @@
               </a:defRPr>
             </a:pPr>
             <a:r>
-              <a:t>Clear demarcation between current implemented state and future roadmap.</a:t>
+              <a:t>Structured 4-week pilot deployment for fee-only advisory practices with verified commercial terms.</a:t>
             </a:r>
           </a:p>
         </p:txBody>
@@ -10689,12 +10845,12 @@
             <a:pPr>
               <a:defRPr b="1" sz="1300">
                 <a:solidFill>
-                  <a:srgbClr val="059669"/>
-                </a:solidFill>
-              </a:defRPr>
-            </a:pPr>
-            <a:r>
-              <a:t>Implemented Production Capabilities</a:t>
+                  <a:srgbClr val="0A192F"/>
+                </a:solidFill>
+              </a:defRPr>
+            </a:pPr>
+            <a:r>
+              <a:t>4-Week Phased Implementation Roadmap</a:t>
             </a:r>
           </a:p>
           <a:p>
@@ -10709,31 +10865,38 @@
               </a:defRPr>
             </a:pPr>
             <a:r>
-              <a:t>• Full non-discretionary mandate formulation &amp; tax engine.</a:t>
-            </a:r>
-            <a:br/>
-            <a:r>
-              <a:t>• AES-256-GCM dual-envelope encryption &amp; PBKDF2 password gate.</a:t>
-            </a:r>
-            <a:br/>
-            <a:r>
-              <a:t>• 256-bit magic links with SHA-256 database hashing &amp; 48h cutoff.</a:t>
-            </a:r>
-            <a:br/>
-            <a:r>
-              <a:t>• In-app mandate chat with explicit non-consent separation.</a:t>
-            </a:r>
-            <a:br/>
-            <a:r>
-              <a:t>• Section 65B electronic compliance receipts with SHA-256 hash chaining.</a:t>
-            </a:r>
-            <a:br/>
-            <a:r>
-              <a:t>• Multi-tenant isolation, RBAC, TOTP MFA, and distributed rate limiting.</a:t>
-            </a:r>
-            <a:br/>
-            <a:r>
-              <a:t>• 8 Indian languages localization with English numerals.</a:t>
+              <a:t>• Week 1: Practice Setup &amp; Governance Configuration</a:t>
+            </a:r>
+            <a:br/>
+            <a:r>
+              <a:t>  Configure SEBI INA registration number (e.g. INA000088921), firm compliance contacts, and staff TOTP MFA.</a:t>
+            </a:r>
+            <a:br/>
+            <a:br/>
+            <a:r>
+              <a:t>• Week 2: Client Roster Ingestion &amp; Masked Verification</a:t>
+            </a:r>
+            <a:br/>
+            <a:r>
+              <a:t>  Import advisory client profiles with validated PAN syntax (XXXXX1234F), DOB attributes, and configure practice rebalancing templates.</a:t>
+            </a:r>
+            <a:br/>
+            <a:br/>
+            <a:r>
+              <a:t>• Week 3: Controlled Pilot Rebalancing Run</a:t>
+            </a:r>
+            <a:br/>
+            <a:r>
+              <a:t>  Execute live mandates with 10–25 client families; demonstrate pre-trade tax visibility and frictionless mobile OTP consent.</a:t>
+            </a:r>
+            <a:br/>
+            <a:br/>
+            <a:r>
+              <a:t>• Week 4: Compliance Officer Review &amp; Production Rollout</a:t>
+            </a:r>
+            <a:br/>
+            <a:r>
+              <a:t>  Audit Section 63 BSA compliance receipts with firm Compliance Officer; transition full practice to automated FinConsent workflows.</a:t>
             </a:r>
           </a:p>
         </p:txBody>
@@ -10813,7 +10976,7 @@
               </a:defRPr>
             </a:pPr>
             <a:r>
-              <a:t>Future Recommendations / Roadmap</a:t>
+              <a:t>Verified Commercial Terms &amp; Pilot Inquiries</a:t>
             </a:r>
           </a:p>
           <a:p>
@@ -10828,19 +10991,34 @@
               </a:defRPr>
             </a:pPr>
             <a:r>
-              <a:t>• Production TRAI DLT SMS Gateway: Current setup disables SMS by policy (using email/in-app). Commercial rollout requires onboarding a DLT-registered SMS provider (Twilio/Gupshup).</a:t>
-            </a:r>
-            <a:br/>
-            <a:r>
-              <a:t>• CloudHSM Key Management: Derives Server Master Key from JWT_SECRET; AWS CloudHSM or KMS recommended for institutional banking.</a:t>
-            </a:r>
-            <a:br/>
-            <a:r>
-              <a:t>• Automated Broker API Execution: Halts at locked Section 65B consent dossiers; direct broker execution (Kite/SmartAPI) planned for future phase.</a:t>
-            </a:r>
-            <a:br/>
-            <a:r>
-              <a:t>• External RFC 3161 Time Stamping: Anchoring ledger roots to an external Time Stamping Authority (TSA).</a:t>
+              <a:t>• Verified Pro Practice Tier: ₹2,499 / month (+ 18% GST statutory cess)</a:t>
+            </a:r>
+            <a:br/>
+            <a:r>
+              <a:t>  Includes up to 100 active mandates/month, unlimited client roster, complete tax engine, and statutory 5-year cryptographic audit ledger retention.</a:t>
+            </a:r>
+            <a:br/>
+            <a:br/>
+            <a:r>
+              <a:t>• Zero Execution Surcharges: FinConsent charges no basis points (bps) or AUM percentages.</a:t>
+            </a:r>
+            <a:br/>
+            <a:br/>
+            <a:r>
+              <a:t>• Synthetic Demonstration Data: All demonstration credentials and client examples are synthetic.</a:t>
+            </a:r>
+            <a:br/>
+            <a:br/>
+            <a:r>
+              <a:t>• Practice Inquiries &amp; Pilot Onboarding:</a:t>
+            </a:r>
+            <a:br/>
+            <a:r>
+              <a:t>  Official Inquiries: compliance@finconsent.in</a:t>
+            </a:r>
+            <a:br/>
+            <a:r>
+              <a:t>  Demonstration Workspace: Prudent Wealth Advisory (SEBI Reg: INA000088921)</a:t>
             </a:r>
           </a:p>
         </p:txBody>
@@ -11064,12 +11242,12 @@
               </a:defRPr>
             </a:pPr>
             <a:r>
-              <a:t>Principal Officer &amp; Founder, Prudent Wealth Advisory (SEBI Reg: INA000018421)</a:t>
-            </a:r>
-          </a:p>
-          <a:p>
-            <a:pPr>
-              <a:defRPr sz="1150">
+              <a:t>Principal Officer &amp; Founder, Prudent Wealth Advisory (SEBI Reg: INA000088921)</a:t>
+            </a:r>
+          </a:p>
+          <a:p>
+            <a:pPr>
+              <a:defRPr sz="1100">
                 <a:solidFill>
                   <a:srgbClr val="475569"/>
                 </a:solidFill>
@@ -11084,7 +11262,15 @@
             </a:r>
             <a:br/>
             <a:r>
-              <a:t>• Regulatory Obligation: Must recommend selling equities and buying debt/gold, but cannot execute without prior written consent and full tax disclosure under SEBI Regulation 19.</a:t>
+              <a:t>• Regulatory Obligation: Must recommend selling equities and buying debt and gold ETF, but cannot execute without prior written consent, documented rationale, and 5-year record-keeping under SEBI Regulation 19.</a:t>
+            </a:r>
+            <a:br/>
+            <a:r>
+              <a:t>• Execution Boundary: FinConsent records consent and maintains audit evidence; trade execution is executed separately via client's broker.</a:t>
+            </a:r>
+            <a:br/>
+            <a:r>
+              <a:t>• Note: Illustrative persona for workflow demonstration.</a:t>
             </a:r>
           </a:p>
         </p:txBody>
@@ -11179,12 +11365,12 @@
               </a:defRPr>
             </a:pPr>
             <a:r>
-              <a:t>HNI Advisory Client | Managing Director, Auto-Tech Firm, Pune (PAN: ABCDE1234F)</a:t>
-            </a:r>
-          </a:p>
-          <a:p>
-            <a:pPr>
-              <a:defRPr sz="1150">
+              <a:t>HNI Advisory Client | Managing Director, Auto-Tech Firm, Pune (Masked PAN: XXXXX1234F)</a:t>
+            </a:r>
+          </a:p>
+          <a:p>
+            <a:pPr>
+              <a:defRPr sz="1100">
                 <a:solidFill>
                   <a:srgbClr val="475569"/>
                 </a:solidFill>
@@ -11200,6 +11386,14 @@
             <a:br/>
             <a:r>
               <a:t>• Need: Demands a frictionless 2-minute mobile authorization flow that clearly explains why securities are being sold and the exact rupee tax liability.</a:t>
+            </a:r>
+            <a:br/>
+            <a:r>
+              <a:t>• Security: Accesses proposal securely via PAN-last-4 + DOB convenience verification PIN defended online by strict rate limiting.</a:t>
+            </a:r>
+            <a:br/>
+            <a:r>
+              <a:t>• Note: Illustrative persona with synthetic credentials.</a:t>
             </a:r>
           </a:p>
         </p:txBody>
@@ -11451,7 +11645,7 @@
               </a:defRPr>
             </a:pPr>
             <a:r>
-              <a:t>SEBI Regulation 19 Violation</a:t>
+              <a:t>SEBI Regulation 19 Compliance Exposure</a:t>
             </a:r>
           </a:p>
           <a:p>
@@ -11463,7 +11657,7 @@
               </a:defRPr>
             </a:pPr>
             <a:r>
-              <a:t>Advisers without cryptographic client consent face cancellation of registration, show-cause notices, and personal penalties during mandatory regulatory inspections.</a:t>
+              <a:t>Failing to maintain contemporaneous records of investment advice, rationale, and documented client agreement for 5 years leaves advisers vulnerable during mandatory SEBI inspections and dispute resolutions.</a:t>
             </a:r>
           </a:p>
         </p:txBody>
@@ -11586,7 +11780,7 @@
               </a:defRPr>
             </a:pPr>
             <a:r>
-              <a:t>Advance Tax Penalties (Sec 234B &amp; 234C)</a:t>
+              <a:t>Advance Tax Penalties (Sec 208, 234B &amp; 234C)</a:t>
             </a:r>
           </a:p>
           <a:p>
@@ -11598,7 +11792,7 @@
               </a:defRPr>
             </a:pPr>
             <a:r>
-              <a:t>Selling equities without advance tax warnings leads to mandatory 1% monthly penal interest, creating direct client friction and fee dissatisfaction.</a:t>
+              <a:t>Selling equities without advance tax warnings risks 1% monthly penal interest if net tax liability reaches ₹10,000; requires planning under Section 234C capital gains installment relief proviso.</a:t>
             </a:r>
           </a:p>
         </p:txBody>
@@ -11721,7 +11915,7 @@
               </a:defRPr>
             </a:pPr>
             <a:r>
-              <a:t>Inadmissible Electronic Evidence</a:t>
+              <a:t>Electronic Evidence Inadmissibility (BSA Sec 63 / Sec 65B)</a:t>
             </a:r>
           </a:p>
           <a:p>
@@ -11733,7 +11927,7 @@
               </a:defRPr>
             </a:pPr>
             <a:r>
-              <a:t>Under Section 65B of the Indian Evidence Act, raw screenshots of WhatsApp messages cannot be admitted into court or arbitration tribunals without device and server hash proof.</a:t>
+              <a:t>Under Section 63 of Bharatiya Sakshya Adhiniyam, 2023 (and erstwhile Section 65B), raw screenshots lack server hash continuity and device provenance required for court or tribunal admissibility.</a:t>
             </a:r>
           </a:p>
         </p:txBody>
@@ -12135,7 +12329,7 @@
               </a:defRPr>
             </a:pPr>
             <a:r>
-              <a:t>Dynamic Union Budget 2024 tax engine. Computes STCG (20%) and LTCG (12.5%) in real time, alerting clients to quarterly advance tax deadlines.</a:t>
+              <a:t>Dynamic Finance Act 2024 tax engine. Computes STCG (20%) and LTCG (12.5% + 4% cess) in real time, alerting clients to quarterly advance tax deadlines.</a:t>
             </a:r>
           </a:p>
         </p:txBody>
@@ -12273,7 +12467,7 @@
               </a:defRPr>
             </a:pPr>
             <a:r>
-              <a:t>AES-256-GCM encryption with dual key wrapping. Protects sensitive financial assets until client unlocks via PAN last 4 digits and DOB.</a:t>
+              <a:t>AES-256-GCM encryption with dual key wrapping and isolated server master key. Protects sensitive financial assets until client unlocks via PAN last 4 digits and DOB.</a:t>
             </a:r>
           </a:p>
         </p:txBody>
@@ -12396,7 +12590,7 @@
               </a:defRPr>
             </a:pPr>
             <a:r>
-              <a:t>3. Frictionless Mobile Consent</a:t>
+              <a:t>3. Secure Mobile Consent Rail</a:t>
             </a:r>
           </a:p>
           <a:p>
@@ -12411,7 +12605,7 @@
               </a:defRPr>
             </a:pPr>
             <a:r>
-              <a:t>Zero-login 256-bit magic links. 360px responsive mobile layout, mandate clarification chat, and TRAI DLT 6-digit OTP verification.</a:t>
+              <a:t>Direct password-protected 256-bit magic links. 360px responsive mobile layout, mandate clarification chat, and secure email/in-app 6-digit OTP verification.</a:t>
             </a:r>
           </a:p>
         </p:txBody>
@@ -12534,7 +12728,7 @@
               </a:defRPr>
             </a:pPr>
             <a:r>
-              <a:t>4. Section 65B Audit Trail</a:t>
+              <a:t>4. Section 63 BSA Audit Ledger</a:t>
             </a:r>
           </a:p>
           <a:p>
@@ -12788,7 +12982,7 @@
               </a:defRPr>
             </a:pPr>
             <a:r>
-              <a:t>Suresh detects 15% equity drift. Drafts ₹11.10L rebalance into corporate debt and gold bonds.</a:t>
+              <a:t>Suresh detects 15% equity drift. Drafts ₹11.10L rebalance into corporate debt ETF and Gold ETF (secondary market).</a:t>
             </a:r>
           </a:p>
           <a:p>
@@ -12910,7 +13104,7 @@
               </a:defRPr>
             </a:pPr>
             <a:r>
-              <a:t>Engine calculates ₹11,440 capital gains tax. Generates 48-hour cutoff window and dispatch link.</a:t>
+              <a:t>Engine calculates ₹11,440 capital gains tax estimate. Generates 48-hour cutoff window and dispatch magic link.</a:t>
             </a:r>
           </a:p>
           <a:p>
@@ -13032,7 +13226,7 @@
               </a:defRPr>
             </a:pPr>
             <a:r>
-              <a:t>Delivered via WhatsApp. Rohan opens link; sensitive data remains encrypted until PAN+DOB unlock.</a:t>
+              <a:t>Delivered via email magic link (WhatsApp on roadmap). Rohan opens link; sensitive data remains encrypted until PAN+DOB unlock.</a:t>
             </a:r>
           </a:p>
           <a:p>
@@ -13154,7 +13348,7 @@
               </a:defRPr>
             </a:pPr>
             <a:r>
-              <a:t>Rohan reviews trade baskets, asks a clarification in mandate chat. Suresh replies; Rohan accepts terms.</a:t>
+              <a:t>Rohan reviews trade baskets, asks a clarification in mandate chat. Suresh replies; Rohan accepts terms (Chat != Consent).</a:t>
             </a:r>
           </a:p>
           <a:p>
@@ -13276,7 +13470,7 @@
               </a:defRPr>
             </a:pPr>
             <a:r>
-              <a:t>Rohan verifies 6-digit OTP. Token revoked; Section 65B compliance dossier locked immutably.</a:t>
+              <a:t>Rohan verifies 6-digit OTP. Token burned; Section 63 BSA compliance dossier locked immutably (trade execution by broker/client).</a:t>
             </a:r>
           </a:p>
           <a:p>
@@ -13422,51 +13616,30 @@
           </a:p>
         </p:txBody>
       </p:sp>
-      <p:sp>
-        <p:nvSpPr>
-          <p:cNvPr id="4" name="Rounded Rectangle 3"/>
-          <p:cNvSpPr/>
-          <p:nvPr/>
-        </p:nvSpPr>
-        <p:spPr>
-          <a:xfrm>
-            <a:off x="731520" y="1828800"/>
-            <a:ext cx="10728655" cy="4389120"/>
-          </a:xfrm>
-          <a:prstGeom prst="roundRect">
-            <a:avLst/>
-          </a:prstGeom>
-          <a:solidFill>
-            <a:srgbClr val="F8FAFC"/>
-          </a:solidFill>
-          <a:ln w="12700">
-            <a:solidFill>
-              <a:srgbClr val="E2E8F0"/>
-            </a:solidFill>
-          </a:ln>
-        </p:spPr>
-        <p:style>
-          <a:lnRef idx="1">
-            <a:schemeClr val="accent1"/>
-          </a:lnRef>
-          <a:fillRef idx="3">
-            <a:schemeClr val="accent1"/>
-          </a:fillRef>
-          <a:effectRef idx="2">
-            <a:schemeClr val="accent1"/>
-          </a:effectRef>
-          <a:fontRef idx="minor">
-            <a:schemeClr val="lt1"/>
-          </a:fontRef>
-        </p:style>
-        <p:txBody>
-          <a:bodyPr rtlCol="0" anchor="ctr"/>
-          <a:lstStyle/>
-          <a:p>
-            <a:pPr algn="ctr"/>
-          </a:p>
-        </p:txBody>
-      </p:sp>
+      <p:pic>
+        <p:nvPicPr>
+          <p:cNvPr id="4" name="Picture 3" descr="process-flow.png"/>
+          <p:cNvPicPr>
+            <a:picLocks noChangeAspect="1"/>
+          </p:cNvPicPr>
+          <p:nvPr/>
+        </p:nvPicPr>
+        <p:blipFill>
+          <a:blip r:embed="rId2"/>
+          <a:stretch>
+            <a:fillRect/>
+          </a:stretch>
+        </p:blipFill>
+        <p:spPr>
+          <a:xfrm>
+            <a:off x="731520" y="1645920"/>
+            <a:ext cx="10728655" cy="4663440"/>
+          </a:xfrm>
+          <a:prstGeom prst="rect">
+            <a:avLst/>
+          </a:prstGeom>
+        </p:spPr>
+      </p:pic>
       <p:sp>
         <p:nvSpPr>
           <p:cNvPr id="5" name="TextBox 4"/>
@@ -13475,8 +13648,8 @@
         </p:nvSpPr>
         <p:spPr>
           <a:xfrm>
-            <a:off x="1005840" y="2103120"/>
-            <a:ext cx="10180015" cy="3840480"/>
+            <a:off x="731520" y="6382512"/>
+            <a:ext cx="10728655" cy="365760"/>
           </a:xfrm>
           <a:prstGeom prst="rect">
             <a:avLst/>
@@ -13484,169 +13657,21 @@
           <a:noFill/>
         </p:spPr>
         <p:txBody>
-          <a:bodyPr wrap="square">
+          <a:bodyPr wrap="square" lIns="0" tIns="0" rIns="0" bIns="0">
             <a:spAutoFit/>
           </a:bodyPr>
           <a:lstStyle/>
           <a:p>
             <a:pPr>
-              <a:defRPr sz="850">
-                <a:solidFill>
-                  <a:srgbClr val="0A192F"/>
-                </a:solidFill>
-                <a:latin typeface="Consolas"/>
-              </a:defRPr>
-            </a:pPr>
-            <a:r>
-              <a:t>[ 1. RIA FORMULATION ]</a:t>
-            </a:r>
-            <a:br/>
-            <a:r>
-              <a:t>   • Portfolio Drift Identified (Equity 65% → 50% target)</a:t>
-            </a:r>
-            <a:br/>
-            <a:r>
-              <a:t>   • Trade baskets constructed (Sell HDFC Bank &amp; Tata Motors; Buy Bharat Bond ETF &amp; SGB)</a:t>
-            </a:r>
-            <a:br/>
-            <a:r>
-              <a:t>   • Advisory Rationale documented under SEBI IA Regulations</a:t>
-            </a:r>
-            <a:br/>
-            <a:r>
-              <a:t>              │</a:t>
-            </a:r>
-            <a:br/>
-            <a:r>
-              <a:t>              ▼</a:t>
-            </a:r>
-            <a:br/>
-            <a:r>
-              <a:t>[ 2. TAX-IMPACT CALCULATION &amp; 48H CUTOFF ]</a:t>
-            </a:r>
-            <a:br/>
-            <a:r>
-              <a:t>   • Union Budget 2024 Engine: STCG @ 20% (₹11,000) + LTCG @ 12.5% (Exempt) + 4% Cess</a:t>
-            </a:r>
-            <a:br/>
-            <a:r>
-              <a:t>   • Section 234B/C Advance Tax notice triggered</a:t>
-            </a:r>
-            <a:br/>
-            <a:r>
-              <a:t>   • 48-Hour execution cutoff timer initialized</a:t>
-            </a:r>
-            <a:br/>
-            <a:r>
-              <a:t>              │</a:t>
-            </a:r>
-            <a:br/>
-            <a:r>
-              <a:t>              ▼</a:t>
-            </a:r>
-            <a:br/>
-            <a:r>
-              <a:t>[ 3. DUAL-ENVELOPE ENCRYPTION &amp; SECURE DISPATCH ]</a:t>
-            </a:r>
-            <a:br/>
-            <a:r>
-              <a:t>   • Sensitive financial payload encrypted via AES-256-GCM</a:t>
-            </a:r>
-            <a:br/>
-            <a:r>
-              <a:t>   • Data Encryption Key (DEK) wrapped for client via PBKDF2(PAN_last4 + DOB)</a:t>
-            </a:r>
-            <a:br/>
-            <a:r>
-              <a:t>   • 256-bit high-entropy magic link dispatched via 1-click WhatsApp template</a:t>
-            </a:r>
-            <a:br/>
-            <a:r>
-              <a:t>              │</a:t>
-            </a:r>
-            <a:br/>
-            <a:r>
-              <a:t>              ▼</a:t>
-            </a:r>
-            <a:br/>
-            <a:r>
-              <a:t>[ 4. CLIENT ACCESS &amp; PASSWORD UNLOCK ]</a:t>
-            </a:r>
-            <a:br/>
-            <a:r>
-              <a:t>   • Rohan Mehta taps link on mobile smartphone (Zero PII visible prior to unlock)</a:t>
-            </a:r>
-            <a:br/>
-            <a:r>
-              <a:t>   • Enters client password (123414081978); browser receives signed 2-hour JWT</a:t>
-            </a:r>
-            <a:br/>
-            <a:r>
-              <a:t>   • Proposal decrypts: trade details, allocation bars, and advance tax calendar displayed</a:t>
-            </a:r>
-            <a:br/>
-            <a:r>
-              <a:t>              │</a:t>
-            </a:r>
-            <a:br/>
-            <a:r>
-              <a:t>              ▼</a:t>
-            </a:r>
-            <a:br/>
-            <a:r>
-              <a:t>[ 5. ADVISORY DISCUSSION &amp; STATUTORY CLARIFICATION ]</a:t>
-            </a:r>
-            <a:br/>
-            <a:r>
-              <a:t>   • In-app Mandate Chat clarifies single-stock risk ceiling on Tata Motors</a:t>
-            </a:r>
-            <a:br/>
-            <a:r>
-              <a:t>   • ⚠️ Legal boundary: Informal chat dialogue explicitly does NOT constitute trade consent</a:t>
-            </a:r>
-            <a:br/>
-            <a:r>
-              <a:t>              │</a:t>
-            </a:r>
-            <a:br/>
-            <a:r>
-              <a:t>              ▼</a:t>
-            </a:r>
-            <a:br/>
-            <a:r>
-              <a:t>[ 6. STATUTORY ACCEPTANCE &amp; 6-DIGIT OTP AUTHORIZATION ]</a:t>
-            </a:r>
-            <a:br/>
-            <a:r>
-              <a:t>   • Explicit acknowledgement of 3 statutory declarations (Reg 19, Tax, Section 65B)</a:t>
-            </a:r>
-            <a:br/>
-            <a:r>
-              <a:t>   • 6-digit cryptographic OTP verified (rate-limited, 3 attempts max before lockout)</a:t>
-            </a:r>
-            <a:br/>
-            <a:r>
-              <a:t>              │</a:t>
-            </a:r>
-            <a:br/>
-            <a:r>
-              <a:t>              ▼</a:t>
-            </a:r>
-            <a:br/>
-            <a:r>
-              <a:t>[ 7. ATOMIC REVOCATION &amp; SECTION 65B EVIDENCE LOCK ]</a:t>
-            </a:r>
-            <a:br/>
-            <a:r>
-              <a:t>   • Magic token permanently revoked to prevent replay attacks; mandate status = CONSENTED</a:t>
-            </a:r>
-            <a:br/>
-            <a:r>
-              <a:t>   • Chained SHA-256 audit record committed (IP, User-Agent, IST timestamp, hash digest)</a:t>
-            </a:r>
-            <a:br/>
-            <a:r>
-              <a:t>   • Official Section 65B Compliance Dossier Certificate generated and downloadable</a:t>
+              <a:defRPr sz="900" i="1">
+                <a:solidFill>
+                  <a:srgbClr val="475569"/>
+                </a:solidFill>
+                <a:latin typeface="Calibri"/>
+              </a:defRPr>
+            </a:pPr>
+            <a:r>
+              <a:t>Figure 7.1: Statutory Process Flow Diagram — SEBI Regulation 19 advisory formulation, Finance Act 2024 tax calculation, OTP authorization, and Section 63 BSA evidence lock.</a:t>
             </a:r>
           </a:p>
         </p:txBody>
@@ -13930,11 +13955,11 @@
               </a:defRPr>
             </a:pPr>
             <a:r>
-              <a:t>• Practice Workspace: Scoped view displaying active mandate statuses (Draft, Sent, Viewed, Consented, Expired) with real-time 48-hour countdown badges.</a:t>
-            </a:r>
-            <a:br/>
-            <a:r>
-              <a:t>• Frictionless Client Registry: Client management enforcing PAN syntax ([A-Z]{5}[0-9]{4}[A-Z]) and mobile number formatting.</a:t>
+              <a:t>• Practice Workspace: Scoped view displaying active mandate statuses (Draft, Sent, Viewed, Consented, Expired, Revoked) with real-time 48-hour countdown badges.</a:t>
+            </a:r>
+            <a:br/>
+            <a:r>
+              <a:t>• Client Registry: Client management enforcing PAN syntax ([A-Z]{5}[0-9]{4}[A-Z]), masked presentation (XXXXX1234F), and mobile number formatting.</a:t>
             </a:r>
             <a:br/>
             <a:r>
@@ -13942,7 +13967,7 @@
             </a:r>
             <a:br/>
             <a:r>
-              <a:t>• Instant Emergency Control: Single-click 'Revoke Link' feature allows advisers to immediately cancel dispatched proposals if market volatility occurs.</a:t>
+              <a:t>• Instant Emergency Revocation: Single-click 'Revoke Link' feature allows advisers to immediately cancel dispatched proposals if market volatility occurs.</a:t>
             </a:r>
           </a:p>
         </p:txBody>
@@ -14226,7 +14251,7 @@
               </a:defRPr>
             </a:pPr>
             <a:r>
-              <a:t>• Zero-Login Convenience: Clients tap the link received via WhatsApp/email without remembering passwords or downloading an app.</a:t>
+              <a:t>• Direct Magic Link Convenience: Clients tap the link received via email without remembering complex portal passwords or downloading an app.</a:t>
             </a:r>
             <a:br/>
             <a:r>
@@ -14234,11 +14259,11 @@
             </a:r>
             <a:br/>
             <a:r>
-              <a:t>• Transparent Trade Baskets: Exact share quantities, current market value, ISIN numbers, and transaction rationale displayed clearly.</a:t>
-            </a:r>
-            <a:br/>
-            <a:r>
-              <a:t>• Tax Accountability: Pre-computes exact rupee liability (₹11,440) so the client understands the net financial impact before consenting.</a:t>
+              <a:t>• Transparent Trade Baskets: Exact share quantities, current market value, ISIN numbers, and transaction rationale displayed clearly (Tata Motors, HDFC Bank -&gt; Bharat Bond, Gold ETF).</a:t>
+            </a:r>
+            <a:br/>
+            <a:r>
+              <a:t>• Tax Accountability: Pre-computes estimated rupee liability (₹11,440) so the client understands the net financial impact before consenting.</a:t>
             </a:r>
           </a:p>
         </p:txBody>

</xml_diff>